<commit_message>
everything that is new
</commit_message>
<xml_diff>
--- a/presentation/FRB_project.pptx
+++ b/presentation/FRB_project.pptx
@@ -207,7 +207,7 @@
           <a:p>
             <a:fld id="{7452E638-4A18-B24D-841C-B7AA22B6187A}" type="datetimeFigureOut">
               <a:rPr lang="en-DE" smtClean="0"/>
-              <a:t>24.09.26</a:t>
+              <a:t>05.10.26</a:t>
             </a:fld>
             <a:endParaRPr lang="en-DE"/>
           </a:p>
@@ -1725,7 +1725,7 @@
           <a:p>
             <a:fld id="{87F987B8-30A4-044B-B021-0E4FEA54139B}" type="datetime1">
               <a:rPr lang="de-DE" smtClean="0"/>
-              <a:t>24.09.26</a:t>
+              <a:t>05.10.26</a:t>
             </a:fld>
             <a:endParaRPr lang="en-DE"/>
           </a:p>
@@ -1899,7 +1899,7 @@
           <a:p>
             <a:fld id="{1AB9055D-9A9B-0745-B98B-ABAE59D3B794}" type="datetime1">
               <a:rPr lang="de-DE" smtClean="0"/>
-              <a:t>24.09.26</a:t>
+              <a:t>05.10.26</a:t>
             </a:fld>
             <a:endParaRPr lang="en-DE"/>
           </a:p>
@@ -2083,7 +2083,7 @@
           <a:p>
             <a:fld id="{DC5738BC-1EE9-3C4F-A3D2-D98FF4219397}" type="datetime1">
               <a:rPr lang="de-DE" smtClean="0"/>
-              <a:t>24.09.26</a:t>
+              <a:t>05.10.26</a:t>
             </a:fld>
             <a:endParaRPr lang="en-DE"/>
           </a:p>
@@ -2257,7 +2257,7 @@
           <a:p>
             <a:fld id="{4112787C-F246-2344-9E35-42282032FB1D}" type="datetime1">
               <a:rPr lang="de-DE" smtClean="0"/>
-              <a:t>24.09.26</a:t>
+              <a:t>05.10.26</a:t>
             </a:fld>
             <a:endParaRPr lang="en-DE"/>
           </a:p>
@@ -2507,7 +2507,7 @@
           <a:p>
             <a:fld id="{9B073C96-97C0-3C4D-8E73-DF5539BB1A4C}" type="datetime1">
               <a:rPr lang="de-DE" smtClean="0"/>
-              <a:t>24.09.26</a:t>
+              <a:t>05.10.26</a:t>
             </a:fld>
             <a:endParaRPr lang="en-DE"/>
           </a:p>
@@ -2743,7 +2743,7 @@
           <a:p>
             <a:fld id="{9760B672-8DC5-C04F-8747-05D9B7A997FB}" type="datetime1">
               <a:rPr lang="de-DE" smtClean="0"/>
-              <a:t>24.09.26</a:t>
+              <a:t>05.10.26</a:t>
             </a:fld>
             <a:endParaRPr lang="en-DE"/>
           </a:p>
@@ -3114,7 +3114,7 @@
           <a:p>
             <a:fld id="{61CC0A0A-985B-4547-B2CD-9D8D6E09CF2A}" type="datetime1">
               <a:rPr lang="de-DE" smtClean="0"/>
-              <a:t>24.09.26</a:t>
+              <a:t>05.10.26</a:t>
             </a:fld>
             <a:endParaRPr lang="en-DE"/>
           </a:p>
@@ -3236,7 +3236,7 @@
           <a:p>
             <a:fld id="{488B59F8-6EB7-EC4A-B43C-0D35C17E4E71}" type="datetime1">
               <a:rPr lang="de-DE" smtClean="0"/>
-              <a:t>24.09.26</a:t>
+              <a:t>05.10.26</a:t>
             </a:fld>
             <a:endParaRPr lang="en-DE"/>
           </a:p>
@@ -3335,7 +3335,7 @@
           <a:p>
             <a:fld id="{F48DC1E5-00C4-B64C-99BB-99E5A1760278}" type="datetime1">
               <a:rPr lang="de-DE" smtClean="0"/>
-              <a:t>24.09.26</a:t>
+              <a:t>05.10.26</a:t>
             </a:fld>
             <a:endParaRPr lang="en-DE"/>
           </a:p>
@@ -3616,7 +3616,7 @@
           <a:p>
             <a:fld id="{14774D7B-B803-B349-B7F4-3607601FA4C1}" type="datetime1">
               <a:rPr lang="de-DE" smtClean="0"/>
-              <a:t>24.09.26</a:t>
+              <a:t>05.10.26</a:t>
             </a:fld>
             <a:endParaRPr lang="en-DE"/>
           </a:p>
@@ -3877,7 +3877,7 @@
           <a:p>
             <a:fld id="{A072F288-7899-0540-A581-2843FFD9E2DE}" type="datetime1">
               <a:rPr lang="de-DE" smtClean="0"/>
-              <a:t>24.09.26</a:t>
+              <a:t>05.10.26</a:t>
             </a:fld>
             <a:endParaRPr lang="en-DE"/>
           </a:p>
@@ -4103,7 +4103,7 @@
           <a:p>
             <a:fld id="{4E215DEA-5C87-CC42-97A2-C776002BE5F5}" type="datetime1">
               <a:rPr lang="de-DE" smtClean="0"/>
-              <a:t>24.09.26</a:t>
+              <a:t>05.10.26</a:t>
             </a:fld>
             <a:endParaRPr lang="en-DE"/>
           </a:p>
@@ -4920,36 +4920,6 @@
           </a:p>
         </p:txBody>
       </p:sp>
-      <p:pic>
-        <p:nvPicPr>
-          <p:cNvPr id="8" name="Picture 7" descr="fisher_kids_vs_lsst_2x2.png">
-            <a:extLst>
-              <a:ext uri="{FF2B5EF4-FFF2-40B4-BE49-F238E27FC236}">
-                <a16:creationId xmlns:a16="http://schemas.microsoft.com/office/drawing/2014/main" id="{86016607-C708-A5F8-A1A5-BEF66953BBA9}"/>
-              </a:ext>
-            </a:extLst>
-          </p:cNvPr>
-          <p:cNvPicPr>
-            <a:picLocks noChangeAspect="1"/>
-          </p:cNvPicPr>
-          <p:nvPr/>
-        </p:nvPicPr>
-        <p:blipFill>
-          <a:blip r:embed="rId3"/>
-          <a:stretch>
-            <a:fillRect/>
-          </a:stretch>
-        </p:blipFill>
-        <p:spPr>
-          <a:xfrm>
-            <a:off x="1178792" y="1417320"/>
-            <a:ext cx="5872015" cy="4892040"/>
-          </a:xfrm>
-          <a:prstGeom prst="rect">
-            <a:avLst/>
-          </a:prstGeom>
-        </p:spPr>
-      </p:pic>
       <p:sp>
         <p:nvSpPr>
           <p:cNvPr id="9" name="Rounded Rectangle 8">
@@ -5491,6 +5461,36 @@
           </a:p>
         </p:txBody>
       </p:sp>
+      <p:pic>
+        <p:nvPicPr>
+          <p:cNvPr id="3" name="Picture 2">
+            <a:extLst>
+              <a:ext uri="{FF2B5EF4-FFF2-40B4-BE49-F238E27FC236}">
+                <a16:creationId xmlns:a16="http://schemas.microsoft.com/office/drawing/2014/main" id="{F326BDE6-6959-0A62-DECC-667916F4CBE1}"/>
+              </a:ext>
+            </a:extLst>
+          </p:cNvPr>
+          <p:cNvPicPr>
+            <a:picLocks noChangeAspect="1"/>
+          </p:cNvPicPr>
+          <p:nvPr/>
+        </p:nvPicPr>
+        <p:blipFill>
+          <a:blip r:embed="rId3"/>
+          <a:stretch>
+            <a:fillRect/>
+          </a:stretch>
+        </p:blipFill>
+        <p:spPr>
+          <a:xfrm>
+            <a:off x="838200" y="1346209"/>
+            <a:ext cx="6085005" cy="5070838"/>
+          </a:xfrm>
+          <a:prstGeom prst="rect">
+            <a:avLst/>
+          </a:prstGeom>
+        </p:spPr>
+      </p:pic>
     </p:spTree>
     <p:extLst>
       <p:ext uri="{BB962C8B-B14F-4D97-AF65-F5344CB8AC3E}">
@@ -6918,8 +6918,8 @@
           </a:p>
         </p:txBody>
       </p:sp>
-      <mc:AlternateContent xmlns:mc="http://schemas.openxmlformats.org/markup-compatibility/2006">
-        <mc:Choice xmlns:a14="http://schemas.microsoft.com/office/drawing/2010/main" Requires="a14">
+      <mc:AlternateContent xmlns:mc="http://schemas.openxmlformats.org/markup-compatibility/2006" xmlns:a14="http://schemas.microsoft.com/office/drawing/2010/main">
+        <mc:Choice Requires="a14">
           <p:sp>
             <p:nvSpPr>
               <p:cNvPr id="3" name="Content Placeholder 2">
@@ -7009,7 +7009,7 @@
             </p:txBody>
           </p:sp>
         </mc:Choice>
-        <mc:Fallback>
+        <mc:Fallback xmlns="">
           <p:sp>
             <p:nvSpPr>
               <p:cNvPr id="3" name="Content Placeholder 2">
@@ -7713,8 +7713,8 @@
           </a:p>
         </p:txBody>
       </p:sp>
-      <mc:AlternateContent xmlns:mc="http://schemas.openxmlformats.org/markup-compatibility/2006">
-        <mc:Choice xmlns:a14="http://schemas.microsoft.com/office/drawing/2010/main" Requires="a14">
+      <mc:AlternateContent xmlns:mc="http://schemas.openxmlformats.org/markup-compatibility/2006" xmlns:a14="http://schemas.microsoft.com/office/drawing/2010/main">
+        <mc:Choice Requires="a14">
           <p:sp>
             <p:nvSpPr>
               <p:cNvPr id="20" name="TextBox 19">
@@ -7743,6 +7743,7 @@
               </a:bodyPr>
               <a:lstStyle/>
               <a:p>
+                <a:pPr/>
                 <a14:m>
                   <m:oMathPara xmlns:m="http://schemas.openxmlformats.org/officeDocument/2006/math">
                     <m:oMath>
@@ -7881,7 +7882,7 @@
             </p:txBody>
           </p:sp>
         </mc:Choice>
-        <mc:Fallback>
+        <mc:Fallback xmlns="">
           <p:sp>
             <p:nvSpPr>
               <p:cNvPr id="20" name="TextBox 19">
@@ -10434,36 +10435,6 @@
           </a:p>
         </p:txBody>
       </p:sp>
-      <p:pic>
-        <p:nvPicPr>
-          <p:cNvPr id="13" name="Picture 12" descr="fisher_comparison_2x2.png">
-            <a:extLst>
-              <a:ext uri="{FF2B5EF4-FFF2-40B4-BE49-F238E27FC236}">
-                <a16:creationId xmlns:a16="http://schemas.microsoft.com/office/drawing/2014/main" id="{4927B330-1C46-5B0F-DFA2-98792069F594}"/>
-              </a:ext>
-            </a:extLst>
-          </p:cNvPr>
-          <p:cNvPicPr>
-            <a:picLocks noChangeAspect="1"/>
-          </p:cNvPicPr>
-          <p:nvPr/>
-        </p:nvPicPr>
-        <p:blipFill>
-          <a:blip r:embed="rId3"/>
-          <a:stretch>
-            <a:fillRect/>
-          </a:stretch>
-        </p:blipFill>
-        <p:spPr>
-          <a:xfrm>
-            <a:off x="1107449" y="1389888"/>
-            <a:ext cx="6014700" cy="5010912"/>
-          </a:xfrm>
-          <a:prstGeom prst="rect">
-            <a:avLst/>
-          </a:prstGeom>
-        </p:spPr>
-      </p:pic>
       <p:sp>
         <p:nvSpPr>
           <p:cNvPr id="14" name="Rounded Rectangle 13">
@@ -11020,6 +10991,36 @@
           </a:p>
         </p:txBody>
       </p:sp>
+      <p:pic>
+        <p:nvPicPr>
+          <p:cNvPr id="3" name="Picture 2">
+            <a:extLst>
+              <a:ext uri="{FF2B5EF4-FFF2-40B4-BE49-F238E27FC236}">
+                <a16:creationId xmlns:a16="http://schemas.microsoft.com/office/drawing/2014/main" id="{C1A01015-9570-616C-C767-947ADB0A51AE}"/>
+              </a:ext>
+            </a:extLst>
+          </p:cNvPr>
+          <p:cNvPicPr>
+            <a:picLocks noChangeAspect="1"/>
+          </p:cNvPicPr>
+          <p:nvPr/>
+        </p:nvPicPr>
+        <p:blipFill>
+          <a:blip r:embed="rId3"/>
+          <a:stretch>
+            <a:fillRect/>
+          </a:stretch>
+        </p:blipFill>
+        <p:spPr>
+          <a:xfrm>
+            <a:off x="1045029" y="1449534"/>
+            <a:ext cx="5919107" cy="4932590"/>
+          </a:xfrm>
+          <a:prstGeom prst="rect">
+            <a:avLst/>
+          </a:prstGeom>
+        </p:spPr>
+      </p:pic>
     </p:spTree>
     <p:extLst>
       <p:ext uri="{BB962C8B-B14F-4D97-AF65-F5344CB8AC3E}">

</xml_diff>